<commit_message>
Add comprehensive documentation and new analyses for PD20-22 campaign
- Introduced a new markdown file `PD20_22_campaign_big_picture.md` detailing the overarching narrative of the PD20-22 campaign, including insights on U.S. Army officer careers and NCAA basketball dynamics.
- Added a PDF version of the campaign overview for easier distribution and reference.
- Updated CSV and JSON files related to the PD21 draft analysis, reflecting new findings and adjustments in the modeling parameters.
- Created new files for the PD21 draft Bernoulli MLE analysis, including gamma grid and profile data, enhancing the analytical framework for player selection dynamics.

These additions provide a clearer understanding of the campaign's objectives and methodologies, supporting ongoing evaluations and presentations.
</commit_message>
<xml_diff>
--- a/3-Master_Plan/re_entry/HEROs_and_PASSes/slides/auto/CHAR_PD21_rho_hsort_calibrate_ppm0lt20_AUTO.pptx
+++ b/3-Master_Plan/re_entry/HEROs_and_PASSes/slides/auto/CHAR_PD21_rho_hsort_calibrate_ppm0lt20_AUTO.pptx
@@ -3145,7 +3145,7 @@
               <a:rPr sz="1000" b="0" i="0" baseline="0">
                 <a:latin typeface="Calibri"/>
               </a:rPr>
-              <a:t>PD21 · LG ASSIGN calibration · 2011-2021 · 50 seeds · bracket tol=0.001 · longitudinal $\rho^* \approx 0.57$ · contrast ppm0lt20</a:t>
+              <a:t>PD21 · LG ASSIGN calibration · 2011-2021 · 50 seeds · bracket tol=0.001 · longitudinal $\rho^* \approx 0.0484$ · contrast ppm0lt20</a:t>
             </a:r>
           </a:p>
         </p:txBody>
@@ -3166,8 +3166,8 @@
         </p:blipFill>
         <p:spPr>
           <a:xfrm>
-            <a:off x="4379976" y="1107353"/>
-            <a:ext cx="7427671" cy="4835317"/>
+            <a:off x="4379976" y="1102132"/>
+            <a:ext cx="7427671" cy="4845760"/>
           </a:xfrm>
           <a:prstGeom prst="rect">
             <a:avLst/>
@@ -3312,7 +3312,7 @@
               <a:rPr sz="1000" b="0" i="0" baseline="0">
                 <a:latin typeface="Calibri"/>
               </a:rPr>
-              <a:t>  Longitudinal $\rho^* \approx 0.5695$; mean $H_{\mathrm{sort}}^{\mathrm{sim}}$ at $\rho^*$ = 0.169; mean $H_{\mathrm{sort}}^{\mathrm{emp}}$ = 0.171.</a:t>
+              <a:t>  Longitudinal $\rho^* \approx 0.04844$; mean $H_{\mathrm{sort}}^{\mathrm{sim}}$ at $\rho^*$ = 0.067; mean $H_{\mathrm{sort}}^{\mathrm{emp}}$ = 0.065.</a:t>
             </a:r>
           </a:p>
           <a:p>
@@ -3332,7 +3332,7 @@
               <a:rPr sz="1000" b="0" i="0" baseline="0">
                 <a:latin typeface="Calibri"/>
               </a:rPr>
-              <a:t>  Per-season: 0/11 seasons at $\rho^*=0$; nonzero — 2011: \rho^* \approx 0.0184, 2012: \rho^* \approx 0.0184, 2013: \rho^* \approx 0.103, 2014: \rho^* \approx 0.569, 2015: \rho^* \approx 0.594, …</a:t>
+              <a:t>  Per-season: 5/11 seasons at $\rho^*=0$; nonzero — 2015: \rho^* \approx 0.184, 2016: \rho^* \approx 0.161, 2017: \rho^* \approx 0.0129, 2018: \rho^* \approx 0.0457, 2019: \rho^* \approx 0.0715, …</a:t>
             </a:r>
           </a:p>
           <a:p>
@@ -3352,7 +3352,7 @@
               <a:rPr sz="1000" b="0" i="0" baseline="0">
                 <a:latin typeface="Calibri"/>
               </a:rPr>
-              <a:t>  Legacy reference $\rho=0.5$: mean $|error| \approx 0.061$ vs $\approx 4.6e-06$ at $\rho^*$.</a:t>
+              <a:t>  Legacy reference $\rho=0.5$: mean $|error| \approx 0.089$ vs $\approx 4.9e-06$ at $\rho^*$.</a:t>
             </a:r>
           </a:p>
           <a:p>
@@ -3372,7 +3372,7 @@
               <a:rPr sz="1000" b="0" i="0" baseline="0">
                 <a:latin typeface="Calibri"/>
               </a:rPr>
-              <a:t>  Figure bottom-right inset: per-season $\rho^*$ — red dots jump at 2014; dotted line = mean $\rho^*$ across seasons.</a:t>
+              <a:t>  Figure bottom-right inset: per-season $\rho^*$ — red dots spike at 2015–2016; dotted line = mean $\rho^*$ across seasons.</a:t>
             </a:r>
           </a:p>
           <a:p>
@@ -3392,7 +3392,7 @@
               <a:rPr sz="1000" b="0" i="0" baseline="0">
                 <a:latin typeface="Calibri"/>
               </a:rPr>
-              <a:t>  2013$\rightarrow$2014 per-season $\rho^*$: $0.103\rightarrow0.569$ — coincides with raw ESPN player-season count jump; not used for locked calibration.</a:t>
+              <a:t>  2014$\rightarrow$2015 per-season $\rho^*$: $0.000\rightarrow0.184$ — mid-decade spike co-moves with empirical $H_{\mathrm{sort}}$; not used for locked calibration.</a:t>
             </a:r>
           </a:p>
           <a:p>
@@ -3412,7 +3412,7 @@
               <a:rPr sz="1000" b="0" i="0" baseline="0">
                 <a:latin typeface="Calibri"/>
               </a:rPr>
-              <a:t>  Contrast slide only: ppm0lt20 (all roster rows, PPM$=0$ if min$&lt;20$, no caps) inflates $\rho^*$ and the 2013$\rightarrow$2014 per-season jump — do not use for locked calibration.</a:t>
+              <a:t>  Contrast slide only: ppm0lt20 (all roster rows, PPM$=0$ if min$&lt;20$, no caps) can yield positive per-season $\rho^*$ where hero drop gives $0$ — do not use for locked calibration.</a:t>
             </a:r>
           </a:p>
           <a:p>
@@ -3504,7 +3504,7 @@
               <a:rPr sz="1100" b="1" i="0" baseline="0">
                 <a:latin typeface="Calibri"/>
               </a:rPr>
-              <a:t>Claim (PD21 contrast): ppm0lt20 inflates longitudinal $\rho^* \approx 0.57$ — not the hero estimand; 2013$\rightarrow$2014 per-season jump traces ESPN box-depth break (PD22 ESPN coverage — HAND20 slide 9).</a:t>
+              <a:t>Claim (PD21 contrast): ppm0lt20 yields modest longitudinal $\rho^* \approx 0.0484$ (hero panel $=0$) — not the locked estimand; 2014$\rightarrow$2015 per-season spike co-moves with mid-decade $H_{\mathrm{sort}}$ on uncapped roster rows (PD22 ESPN coverage — HAND20 slide 9).</a:t>
             </a:r>
           </a:p>
         </p:txBody>

</xml_diff>